<commit_message>
Fix technical presentation coherence: feature count, recall, macro F1
- Slide 4: 6 → 5 domain-derived features; remove tcp_udp_flags entry
- Slide 6: 78 Raw + 6 Eng = 84 → 66 Base + 5 Eng = 71
- Slide 10: Attack Recall 0.983 → 0.999; fix model verdict metrics

Co-Authored-By: Claude Sonnet 4.6 <noreply@anthropic.com>
</commit_message>
<xml_diff>
--- a/reports/technical_presentation.pptx
+++ b/reports/technical_presentation.pptx
@@ -2573,7 +2573,7 @@
                 <a:ea typeface="Calibri" pitchFamily="34" charset="-122"/>
                 <a:cs typeface="Calibri" pitchFamily="34" charset="-120"/>
               </a:rPr>
-              <a:t>0.983</a:t>
+              <a:t>0.999</a:t>
             </a:r>
             <a:endParaRPr lang="en-US" sz="4400" dirty="0"/>
           </a:p>
@@ -3594,7 +3594,7 @@
                 <a:ea typeface="Calibri" pitchFamily="34" charset="-122"/>
                 <a:cs typeface="Calibri" pitchFamily="34" charset="-120"/>
               </a:rPr>
-              <a:t>Best AUC-ROC (0.999), Macro F1 (0.967), and Recall (0.983). SHAP-compatible. Regularisation reduces overfitting risk.
+              <a:t>Best AUC-ROC (1.000), Binary Macro F1 (0.998), and Attack Recall (0.999). SHAP-compatible. Regularisation reduces overfitting risk.
 </a:t>
             </a:r>
             <a:pPr indent="0" marL="0">
@@ -7382,7 +7382,7 @@
                 <a:ea typeface="Calibri" pitchFamily="34" charset="-122"/>
                 <a:cs typeface="Calibri" pitchFamily="34" charset="-120"/>
               </a:rPr>
-              <a:t>6 Domain-Derived Features</a:t>
+              <a:t>5 Domain-Derived Features</a:t>
             </a:r>
             <a:endParaRPr lang="en-US" sz="1300" dirty="0"/>
           </a:p>
@@ -7927,84 +7927,6 @@
             <a:prstDash val="solid"/>
           </a:ln>
         </p:spPr>
-      </p:sp>
-      <p:sp>
-        <p:nvSpPr>
-          <p:cNvPr id="46" name="Text 44"/>
-          <p:cNvSpPr/>
-          <p:nvPr/>
-        </p:nvSpPr>
-        <p:spPr>
-          <a:xfrm>
-            <a:off x="4892040" y="4023360"/>
-            <a:ext cx="3749040" cy="228600"/>
-          </a:xfrm>
-          <a:prstGeom prst="rect">
-            <a:avLst/>
-          </a:prstGeom>
-          <a:noFill/>
-          <a:ln/>
-        </p:spPr>
-        <p:txBody>
-          <a:bodyPr wrap="square" lIns="0" tIns="0" rIns="0" bIns="0" rtlCol="0" anchor="ctr"/>
-          <a:lstStyle/>
-          <a:p>
-            <a:pPr indent="0" marL="0">
-              <a:buNone/>
-            </a:pPr>
-            <a:r>
-              <a:rPr lang="en-US" sz="1100" b="1" dirty="0">
-                <a:solidFill>
-                  <a:srgbClr val="F5A623"/>
-                </a:solidFill>
-                <a:latin typeface="Calibri" pitchFamily="34" charset="0"/>
-                <a:ea typeface="Calibri" pitchFamily="34" charset="-122"/>
-                <a:cs typeface="Calibri" pitchFamily="34" charset="-120"/>
-              </a:rPr>
-              <a:t>tcp_udp_flags</a:t>
-            </a:r>
-            <a:endParaRPr lang="en-US" sz="1100" dirty="0"/>
-          </a:p>
-        </p:txBody>
-      </p:sp>
-      <p:sp>
-        <p:nvSpPr>
-          <p:cNvPr id="47" name="Text 45"/>
-          <p:cNvSpPr/>
-          <p:nvPr/>
-        </p:nvSpPr>
-        <p:spPr>
-          <a:xfrm>
-            <a:off x="4892040" y="4233672"/>
-            <a:ext cx="3749040" cy="201168"/>
-          </a:xfrm>
-          <a:prstGeom prst="rect">
-            <a:avLst/>
-          </a:prstGeom>
-          <a:noFill/>
-          <a:ln/>
-        </p:spPr>
-        <p:txBody>
-          <a:bodyPr wrap="square" lIns="0" tIns="0" rIns="0" bIns="0" rtlCol="0" anchor="ctr"/>
-          <a:lstStyle/>
-          <a:p>
-            <a:pPr indent="0" marL="0">
-              <a:buNone/>
-            </a:pPr>
-            <a:r>
-              <a:rPr lang="en-US" sz="1000" dirty="0">
-                <a:solidFill>
-                  <a:srgbClr val="D8E8F4"/>
-                </a:solidFill>
-                <a:latin typeface="Calibri" pitchFamily="34" charset="0"/>
-                <a:ea typeface="Calibri" pitchFamily="34" charset="-122"/>
-                <a:cs typeface="Calibri" pitchFamily="34" charset="-120"/>
-              </a:rPr>
-              <a:t>Explicit binary protocol indicators for linear models</a:t>
-            </a:r>
-            <a:endParaRPr lang="en-US" sz="1000" dirty="0"/>
-          </a:p>
-        </p:txBody>
       </p:sp>
     </p:spTree>
   </p:cSld>
@@ -8991,7 +8913,7 @@
                 <a:ea typeface="Calibri" pitchFamily="34" charset="-122"/>
                 <a:cs typeface="Calibri" pitchFamily="34" charset="-120"/>
               </a:rPr>
-              <a:t>78 Raw</a:t>
+              <a:t>66 Base</a:t>
             </a:r>
             <a:endParaRPr lang="en-US" sz="900" dirty="0"/>
           </a:p>
@@ -9008,7 +8930,7 @@
                 <a:ea typeface="Calibri" pitchFamily="34" charset="-122"/>
                 <a:cs typeface="Calibri" pitchFamily="34" charset="-120"/>
               </a:rPr>
-              <a:t>+ 6 Engineered</a:t>
+              <a:t>+ 5 Engineered</a:t>
             </a:r>
             <a:endParaRPr lang="en-US" sz="900" dirty="0"/>
           </a:p>
@@ -9025,7 +8947,7 @@
                 <a:ea typeface="Calibri" pitchFamily="34" charset="-122"/>
                 <a:cs typeface="Calibri" pitchFamily="34" charset="-120"/>
               </a:rPr>
-              <a:t>= 84 Features</a:t>
+              <a:t>= 71 Features</a:t>
             </a:r>
             <a:endParaRPr lang="en-US" sz="900" dirty="0"/>
           </a:p>

</xml_diff>